<commit_message>
docs: refresh Pond demo and slides after Thai UI update
</commit_message>
<xml_diff>
--- a/doc/slide/pond-self-service.pptx
+++ b/doc/slide/pond-self-service.pptx
@@ -2,18 +2,18 @@
 <file path=ppt/presentation.xml><?xml version="1.0" encoding="utf-8"?>
 <p:presentation xmlns:p="http://schemas.openxmlformats.org/presentationml/2006/main">
   <p:sldMasterIdLst>
-    <p:sldMasterId xmlns:r="http://schemas.openxmlformats.org/officeDocument/2006/relationships" id="2147483648" r:id="R8fb0a02fb97545aa"/>
+    <p:sldMasterId xmlns:r="http://schemas.openxmlformats.org/officeDocument/2006/relationships" id="2147483648" r:id="Re4e25195fec6480e"/>
   </p:sldMasterIdLst>
   <p:notesMasterIdLst>
-    <p:notesMasterId xmlns:r="http://schemas.openxmlformats.org/officeDocument/2006/relationships" r:id="R9487bfecaa1b4123"/>
+    <p:notesMasterId xmlns:r="http://schemas.openxmlformats.org/officeDocument/2006/relationships" r:id="R214ed3625cc343d3"/>
   </p:notesMasterIdLst>
   <p:sldIdLst>
-    <p:sldId xmlns:r="http://schemas.openxmlformats.org/officeDocument/2006/relationships" id="256" r:id="R074270d7c2d744f0"/>
-    <p:sldId xmlns:r="http://schemas.openxmlformats.org/officeDocument/2006/relationships" id="257" r:id="R326ff04b87314572"/>
-    <p:sldId xmlns:r="http://schemas.openxmlformats.org/officeDocument/2006/relationships" id="258" r:id="R3271bd3cd0864e54"/>
-    <p:sldId xmlns:r="http://schemas.openxmlformats.org/officeDocument/2006/relationships" id="259" r:id="Re9906eedecc84f4e"/>
-    <p:sldId xmlns:r="http://schemas.openxmlformats.org/officeDocument/2006/relationships" id="260" r:id="Re88cba3b13114ef7"/>
-    <p:sldId xmlns:r="http://schemas.openxmlformats.org/officeDocument/2006/relationships" id="261" r:id="Radda2a6806b746ed"/>
+    <p:sldId xmlns:r="http://schemas.openxmlformats.org/officeDocument/2006/relationships" id="256" r:id="Ra3e8b190904b4eb3"/>
+    <p:sldId xmlns:r="http://schemas.openxmlformats.org/officeDocument/2006/relationships" id="257" r:id="R93cb04249bf5437f"/>
+    <p:sldId xmlns:r="http://schemas.openxmlformats.org/officeDocument/2006/relationships" id="258" r:id="Rf1feb85775fa4f8a"/>
+    <p:sldId xmlns:r="http://schemas.openxmlformats.org/officeDocument/2006/relationships" id="259" r:id="R26d659aac77e42fb"/>
+    <p:sldId xmlns:r="http://schemas.openxmlformats.org/officeDocument/2006/relationships" id="260" r:id="Re5fa31d3e34f4267"/>
+    <p:sldId xmlns:r="http://schemas.openxmlformats.org/officeDocument/2006/relationships" id="261" r:id="Rb74b7a05b2184789"/>
   </p:sldIdLst>
   <p:sldSz cx="12192000" cy="6858000"/>
   <p:notesSz cx="6858000" cy="9144000"/>
@@ -447,12 +447,12 @@
           <a:lstStyle xmlns:a="http://schemas.openxmlformats.org/drawingml/2006/main"/>
           <a:p xmlns:a="http://schemas.openxmlformats.org/drawingml/2006/main">
             <a:r>
-              <a:t>0:00–0:40 อธิบายขอบเขตงานตัวเอง เปิด SelfServiceWebController.java:30 เพื่อแสดง constructor injection ของ service interfaces</a:t>
+              <a:t>0:00–0:40 อธิบายขอบเขตงานตัวเอง เปิด SelfServiceWebController.java:34 เพื่อแสดง constructor injection ของ service interfaces</a:t>
             </a:r>
           </a:p>
           <a:p xmlns:a="http://schemas.openxmlformats.org/drawingml/2006/main">
             <a:r>
-              <a:t>แหล่งข้อมูล: develop 9a11daa, code/src/main/java/com/laundryhub/controller/web/SelfServiceWebController.java:30; doc/report/pond-sections.md</a:t>
+              <a:t>แหล่งข้อมูล: develop bf9d636 หลัง PR #37, code/src/main/java/com/laundryhub/controller/web/SelfServiceWebController.java:34; doc/report/pond-sections.md</a:t>
             </a:r>
           </a:p>
         </p:txBody>
@@ -747,12 +747,12 @@
           <a:lstStyle xmlns:a="http://schemas.openxmlformats.org/drawingml/2006/main"/>
           <a:p xmlns:a="http://schemas.openxmlformats.org/drawingml/2006/main">
             <a:r>
-              <a:t>3:30–4:30 เดโมหรือใช้ภาพสำรอง ระบุว่าจ่าย QR จำลอง ไม่ใช่เงินจริง Session 1, Payment 1, Machine 2; ยอด 60.00 ชำระแล้ว Start IN_USE จากนั้น Finish COMPLETED และเครื่อง AVAILABLE; Notification ครบ4ขั้น</a:t>
+              <a:t>3:30–4:30 เดโมหรือใช้ภาพสำรอง ระบุว่าจ่าย QR จำลอง ไม่ใช่เงินจริง Session 5, Payment 4, Machine 2; ยอด 60.00 ชำระแล้ว Start IN_USE จากนั้น Finish COMPLETED และเครื่อง AVAILABLE; Notification ครบ4ขั้น; หลังจ่ายปุ่มชำระหาย แสดงส่งรายการชำระเงินแล้ว; UI badge ภาษาไทย</a:t>
             </a:r>
           </a:p>
           <a:p xmlns:a="http://schemas.openxmlformats.org/drawingml/2006/main">
             <a:r>
-              <a:t>แหล่งข้อมูล: doc/report/pond-deploy-demo.md; ภาพ browser จริง output/pond-demo/05-completed.png และ06-machine-available.png; https://laundry-hub-1ltc.onrender.com ตรวจ10ตุลาคม2569 ไม่ยืนยันdeployment SHA</a:t>
+              <a:t>แหล่งข้อมูล: doc/report/pond-deploy-demo.md; ภาพ browser จริง img/pond-demo-05-completed.png และimg/pond-demo-06-machine-available.png; https://laundry-hub-1ltc.onrender.com ตรวจ10ตุลาคม2569 ไม่ยืนยันdeployment SHA</a:t>
             </a:r>
           </a:p>
         </p:txBody>
@@ -822,7 +822,7 @@
           <a:lstStyle xmlns:a="http://schemas.openxmlformats.org/drawingml/2006/main"/>
           <a:p xmlns:a="http://schemas.openxmlformats.org/drawingml/2006/main">
             <a:r>
-              <a:t>4:30–5:00 อธิบายข้อจำกัดตรงไปตรงมา ผล DB suite357/0skipเป็นผลรอบก่อน ไม่ใช้แทนรอบล่าสุด 369/36skip HTTP Render anonymous GETmachines401และrepeatfinish400 พีชปรับclassdiagram โอ๊ครวมcitation5จุด</a:t>
+              <a:t>4:30–5:00 อธิบายข้อจำกัดตรงไปตรงมา ผล DB suite357/0skipเป็นผลรอบก่อน ไม่ใช้แทนรอบล่าสุด 376/36skip HTTP Render anonymous GETmachines401และrepeatfinish400 พีชปรับclassdiagram โอ๊ครวมcitation5จุด</a:t>
             </a:r>
           </a:p>
           <a:p xmlns:a="http://schemas.openxmlformats.org/drawingml/2006/main">
@@ -874,7 +874,7 @@
           <p:cNvPr id="3" name="Title">
             <a:extLst xmlns:a="http://schemas.openxmlformats.org/drawingml/2006/main">
               <a:ext uri="{FF2B5EF4-FFF2-40B4-BE49-F238E27FC236}">
-                <a16:creationId xmlns:a16="http://schemas.microsoft.com/office/drawing/2014/main" id="{89E0C9C7-84DE-413C-A4C8-B036F7FC02BB}"/>
+                <a16:creationId xmlns:a16="http://schemas.microsoft.com/office/drawing/2014/main" id="{868C53B3-1679-401A-BA99-4EC2360CB904}"/>
               </a:ext>
             </a:extLst>
           </p:cNvPr>
@@ -1031,7 +1031,7 @@
           <p:cNvPr id="2" name="Subtitle">
             <a:extLst xmlns:a="http://schemas.openxmlformats.org/drawingml/2006/main">
               <a:ext uri="{FF2B5EF4-FFF2-40B4-BE49-F238E27FC236}">
-                <a16:creationId xmlns:a16="http://schemas.microsoft.com/office/drawing/2014/main" id="{9E682D94-05AA-4A34-9E0C-8D5AFB0BCD39}"/>
+                <a16:creationId xmlns:a16="http://schemas.microsoft.com/office/drawing/2014/main" id="{19A8B500-9041-4BEA-9E39-47CA8C7F3D9C}"/>
               </a:ext>
             </a:extLst>
           </p:cNvPr>
@@ -1205,7 +1205,7 @@
           <p:cNvPr id="2" name="Section title">
             <a:extLst xmlns:a="http://schemas.openxmlformats.org/drawingml/2006/main">
               <a:ext uri="{FF2B5EF4-FFF2-40B4-BE49-F238E27FC236}">
-                <a16:creationId xmlns:a16="http://schemas.microsoft.com/office/drawing/2014/main" id="{1B06824E-095C-4C87-9557-C2CA8C0D5CE4}"/>
+                <a16:creationId xmlns:a16="http://schemas.microsoft.com/office/drawing/2014/main" id="{9E1E0E8F-EACE-41C7-B18B-EBBD946F149B}"/>
               </a:ext>
             </a:extLst>
           </p:cNvPr>
@@ -1379,7 +1379,7 @@
           <p:cNvPr id="3" name="Title">
             <a:extLst xmlns:a="http://schemas.openxmlformats.org/drawingml/2006/main">
               <a:ext uri="{FF2B5EF4-FFF2-40B4-BE49-F238E27FC236}">
-                <a16:creationId xmlns:a16="http://schemas.microsoft.com/office/drawing/2014/main" id="{17721C94-8ADF-4329-A7FE-C2CCFEF100FB}"/>
+                <a16:creationId xmlns:a16="http://schemas.microsoft.com/office/drawing/2014/main" id="{BA97A5C8-6C34-41E7-92DC-57160CB58949}"/>
               </a:ext>
             </a:extLst>
           </p:cNvPr>
@@ -1536,7 +1536,7 @@
           <p:cNvPr id="2" name="Body">
             <a:extLst xmlns:a="http://schemas.openxmlformats.org/drawingml/2006/main">
               <a:ext uri="{FF2B5EF4-FFF2-40B4-BE49-F238E27FC236}">
-                <a16:creationId xmlns:a16="http://schemas.microsoft.com/office/drawing/2014/main" id="{C08D879D-567B-4188-A7BA-7C8C339DCBCF}"/>
+                <a16:creationId xmlns:a16="http://schemas.microsoft.com/office/drawing/2014/main" id="{7B787DA6-BAAF-4567-A70B-126F6B2ED76E}"/>
               </a:ext>
             </a:extLst>
           </p:cNvPr>
@@ -1710,7 +1710,7 @@
           <p:cNvPr id="4" name="Title">
             <a:extLst xmlns:a="http://schemas.openxmlformats.org/drawingml/2006/main">
               <a:ext uri="{FF2B5EF4-FFF2-40B4-BE49-F238E27FC236}">
-                <a16:creationId xmlns:a16="http://schemas.microsoft.com/office/drawing/2014/main" id="{0FBAA3BC-7B50-48B7-B503-65008E9D0DF2}"/>
+                <a16:creationId xmlns:a16="http://schemas.microsoft.com/office/drawing/2014/main" id="{E718B6E9-4A52-4252-A84B-57F5322F0752}"/>
               </a:ext>
             </a:extLst>
           </p:cNvPr>
@@ -1867,7 +1867,7 @@
           <p:cNvPr id="2" name="Left column">
             <a:extLst xmlns:a="http://schemas.openxmlformats.org/drawingml/2006/main">
               <a:ext uri="{FF2B5EF4-FFF2-40B4-BE49-F238E27FC236}">
-                <a16:creationId xmlns:a16="http://schemas.microsoft.com/office/drawing/2014/main" id="{2E6079E0-BBAB-4D54-82BF-E3237EB2D3DC}"/>
+                <a16:creationId xmlns:a16="http://schemas.microsoft.com/office/drawing/2014/main" id="{F1D8063F-4709-46E5-8A7F-768CA5ACED28}"/>
               </a:ext>
             </a:extLst>
           </p:cNvPr>
@@ -2024,7 +2024,7 @@
           <p:cNvPr id="3" name="Right column">
             <a:extLst xmlns:a="http://schemas.openxmlformats.org/drawingml/2006/main">
               <a:ext uri="{FF2B5EF4-FFF2-40B4-BE49-F238E27FC236}">
-                <a16:creationId xmlns:a16="http://schemas.microsoft.com/office/drawing/2014/main" id="{E95B009C-2445-4EC2-8259-79BC2D19C18D}"/>
+                <a16:creationId xmlns:a16="http://schemas.microsoft.com/office/drawing/2014/main" id="{FDD3467C-21A2-4EDD-9DB0-30A043E36009}"/>
               </a:ext>
             </a:extLst>
           </p:cNvPr>
@@ -2198,7 +2198,7 @@
           <p:cNvPr id="3" name="Title">
             <a:extLst xmlns:a="http://schemas.openxmlformats.org/drawingml/2006/main">
               <a:ext uri="{FF2B5EF4-FFF2-40B4-BE49-F238E27FC236}">
-                <a16:creationId xmlns:a16="http://schemas.microsoft.com/office/drawing/2014/main" id="{A36AA9B9-A0D1-412B-B114-BFF657BC014F}"/>
+                <a16:creationId xmlns:a16="http://schemas.microsoft.com/office/drawing/2014/main" id="{4F230FAF-DE5F-448C-81A3-B30209A7040A}"/>
               </a:ext>
             </a:extLst>
           </p:cNvPr>
@@ -2355,7 +2355,7 @@
           <p:cNvPr id="2" name="Left column">
             <a:extLst xmlns:a="http://schemas.openxmlformats.org/drawingml/2006/main">
               <a:ext uri="{FF2B5EF4-FFF2-40B4-BE49-F238E27FC236}">
-                <a16:creationId xmlns:a16="http://schemas.microsoft.com/office/drawing/2014/main" id="{D2A58819-7E01-4439-8BC9-5D2BD26A6E3C}"/>
+                <a16:creationId xmlns:a16="http://schemas.microsoft.com/office/drawing/2014/main" id="{EDDCA8A5-B4A4-4DAE-B7E8-711D166C29C4}"/>
               </a:ext>
             </a:extLst>
           </p:cNvPr>
@@ -2550,12 +2550,12 @@
   </p:cSld>
   <p:clrMap bg1="lt1" tx1="dk1" bg2="lt2" tx2="dk2" accent1="accent1" accent2="accent2" accent3="accent3" accent4="accent4" accent5="accent5" accent6="accent6" hlink="hlink" folHlink="folHlink"/>
   <p:sldLayoutIdLst>
-    <p:sldLayoutId xmlns:r="http://schemas.openxmlformats.org/officeDocument/2006/relationships" id="2147483649" r:id="R8ae86c90eb714462"/>
-    <p:sldLayoutId xmlns:r="http://schemas.openxmlformats.org/officeDocument/2006/relationships" id="2147483650" r:id="Rfe21ee318dc94c0c"/>
-    <p:sldLayoutId xmlns:r="http://schemas.openxmlformats.org/officeDocument/2006/relationships" id="2147483651" r:id="Rdab3b43a1ce94acf"/>
-    <p:sldLayoutId xmlns:r="http://schemas.openxmlformats.org/officeDocument/2006/relationships" id="2147483652" r:id="R2952be5fba444700"/>
-    <p:sldLayoutId xmlns:r="http://schemas.openxmlformats.org/officeDocument/2006/relationships" id="2147483653" r:id="Rcf9b18b00e7b488d"/>
-    <p:sldLayoutId xmlns:r="http://schemas.openxmlformats.org/officeDocument/2006/relationships" id="2147483654" r:id="Rdbe8a85550774420"/>
+    <p:sldLayoutId xmlns:r="http://schemas.openxmlformats.org/officeDocument/2006/relationships" id="2147483649" r:id="R66ae8bbe2e13427e"/>
+    <p:sldLayoutId xmlns:r="http://schemas.openxmlformats.org/officeDocument/2006/relationships" id="2147483650" r:id="Re5d7e8a4be084976"/>
+    <p:sldLayoutId xmlns:r="http://schemas.openxmlformats.org/officeDocument/2006/relationships" id="2147483651" r:id="Rebf01b3ea91c4ac9"/>
+    <p:sldLayoutId xmlns:r="http://schemas.openxmlformats.org/officeDocument/2006/relationships" id="2147483652" r:id="Rafd6810efe654375"/>
+    <p:sldLayoutId xmlns:r="http://schemas.openxmlformats.org/officeDocument/2006/relationships" id="2147483653" r:id="Rf467a571d0fa40c7"/>
+    <p:sldLayoutId xmlns:r="http://schemas.openxmlformats.org/officeDocument/2006/relationships" id="2147483654" r:id="Ra26c5fa8c9bb4ed5"/>
   </p:sldLayoutIdLst>
   <p:txStyles>
     <p:titleStyle>
@@ -3106,7 +3106,7 @@
           <p:cNvPr id="7" name="">
             <a:extLst xmlns:a="http://schemas.openxmlformats.org/drawingml/2006/main">
               <a:ext uri="{FF2B5EF4-FFF2-40B4-BE49-F238E27FC236}">
-                <a16:creationId xmlns:a16="http://schemas.microsoft.com/office/drawing/2014/main" id="{CA100F02-529A-4407-AB83-7BDB2C6A5810}"/>
+                <a16:creationId xmlns:a16="http://schemas.microsoft.com/office/drawing/2014/main" id="{3AD81703-A9DC-4B41-99A9-A88D43F8F00C}"/>
               </a:ext>
             </a:extLst>
           </p:cNvPr>
@@ -3172,7 +3172,7 @@
           <p:cNvPr id="2" name="">
             <a:extLst xmlns:a="http://schemas.openxmlformats.org/drawingml/2006/main">
               <a:ext uri="{FF2B5EF4-FFF2-40B4-BE49-F238E27FC236}">
-                <a16:creationId xmlns:a16="http://schemas.microsoft.com/office/drawing/2014/main" id="{E4812106-B4A3-4C1B-899D-0282706B78C7}"/>
+                <a16:creationId xmlns:a16="http://schemas.microsoft.com/office/drawing/2014/main" id="{39C53CE1-595B-46F5-89F4-8A68653967C6}"/>
               </a:ext>
             </a:extLst>
           </p:cNvPr>
@@ -3238,7 +3238,7 @@
           <p:cNvPr id="3" name="">
             <a:extLst xmlns:a="http://schemas.openxmlformats.org/drawingml/2006/main">
               <a:ext uri="{FF2B5EF4-FFF2-40B4-BE49-F238E27FC236}">
-                <a16:creationId xmlns:a16="http://schemas.microsoft.com/office/drawing/2014/main" id="{3C329372-129E-403F-9643-00FAFAD1E6E7}"/>
+                <a16:creationId xmlns:a16="http://schemas.microsoft.com/office/drawing/2014/main" id="{0737B2DB-D75B-4975-9558-A51D379BCAA5}"/>
               </a:ext>
             </a:extLst>
           </p:cNvPr>
@@ -3304,7 +3304,7 @@
           <p:cNvPr id="4" name="">
             <a:extLst xmlns:a="http://schemas.openxmlformats.org/drawingml/2006/main">
               <a:ext uri="{FF2B5EF4-FFF2-40B4-BE49-F238E27FC236}">
-                <a16:creationId xmlns:a16="http://schemas.microsoft.com/office/drawing/2014/main" id="{B02093C1-162C-47D2-826A-4FE7562102E4}"/>
+                <a16:creationId xmlns:a16="http://schemas.microsoft.com/office/drawing/2014/main" id="{00E89685-D863-4DBF-9882-BFEB2879C7AF}"/>
               </a:ext>
             </a:extLst>
           </p:cNvPr>
@@ -3370,7 +3370,7 @@
           <p:cNvPr id="5" name="">
             <a:extLst xmlns:a="http://schemas.openxmlformats.org/drawingml/2006/main">
               <a:ext uri="{FF2B5EF4-FFF2-40B4-BE49-F238E27FC236}">
-                <a16:creationId xmlns:a16="http://schemas.microsoft.com/office/drawing/2014/main" id="{9B6387A4-C6A2-4548-BC18-FF135AE3772C}"/>
+                <a16:creationId xmlns:a16="http://schemas.microsoft.com/office/drawing/2014/main" id="{C12661E5-C831-4A95-90CC-5FAA1236E83A}"/>
               </a:ext>
             </a:extLst>
           </p:cNvPr>
@@ -3436,7 +3436,7 @@
           <p:cNvPr id="6" name="">
             <a:extLst xmlns:a="http://schemas.openxmlformats.org/drawingml/2006/main">
               <a:ext uri="{FF2B5EF4-FFF2-40B4-BE49-F238E27FC236}">
-                <a16:creationId xmlns:a16="http://schemas.microsoft.com/office/drawing/2014/main" id="{5504264E-2322-4FCB-8E32-7B478BD2AE0B}"/>
+                <a16:creationId xmlns:a16="http://schemas.microsoft.com/office/drawing/2014/main" id="{93951CA2-ED6C-4D06-B817-F91F74E83639}"/>
               </a:ext>
             </a:extLst>
           </p:cNvPr>
@@ -3500,7 +3500,7 @@
     </p:spTree>
     <p:extLst>
       <p:ext uri="{BB962C8B-B14F-4D97-AF65-F5344CB8AC3E}">
-        <p14:creationId xmlns:p14="http://schemas.microsoft.com/office/powerpoint/2010/main" val="416656453"/>
+        <p14:creationId xmlns:p14="http://schemas.microsoft.com/office/powerpoint/2010/main" val="1917243673"/>
       </p:ext>
     </p:extLst>
   </p:cSld>
@@ -3531,7 +3531,7 @@
           <p:cNvPr id="7" name="">
             <a:extLst xmlns:a="http://schemas.openxmlformats.org/drawingml/2006/main">
               <a:ext uri="{FF2B5EF4-FFF2-40B4-BE49-F238E27FC236}">
-                <a16:creationId xmlns:a16="http://schemas.microsoft.com/office/drawing/2014/main" id="{B4BC66B1-520C-4F80-B573-0592D026C719}"/>
+                <a16:creationId xmlns:a16="http://schemas.microsoft.com/office/drawing/2014/main" id="{952B1208-06F3-411E-B7E1-9A885F7EE952}"/>
               </a:ext>
             </a:extLst>
           </p:cNvPr>
@@ -3597,7 +3597,7 @@
           <p:cNvPr id="2" name="">
             <a:extLst xmlns:a="http://schemas.openxmlformats.org/drawingml/2006/main">
               <a:ext uri="{FF2B5EF4-FFF2-40B4-BE49-F238E27FC236}">
-                <a16:creationId xmlns:a16="http://schemas.microsoft.com/office/drawing/2014/main" id="{777E930D-8998-44D4-8132-BA84F3AA2BAA}"/>
+                <a16:creationId xmlns:a16="http://schemas.microsoft.com/office/drawing/2014/main" id="{B49BF47E-A149-41C2-8E31-92D8E9A2576E}"/>
               </a:ext>
             </a:extLst>
           </p:cNvPr>
@@ -3663,7 +3663,7 @@
           <p:cNvPr id="3" name="">
             <a:extLst xmlns:a="http://schemas.openxmlformats.org/drawingml/2006/main">
               <a:ext uri="{FF2B5EF4-FFF2-40B4-BE49-F238E27FC236}">
-                <a16:creationId xmlns:a16="http://schemas.microsoft.com/office/drawing/2014/main" id="{C4076B48-ECCD-4DC1-B07C-D11259558EF1}"/>
+                <a16:creationId xmlns:a16="http://schemas.microsoft.com/office/drawing/2014/main" id="{5FC20B28-BE73-4544-8AEA-75887387BBD9}"/>
               </a:ext>
             </a:extLst>
           </p:cNvPr>
@@ -3729,7 +3729,7 @@
           <p:cNvPr id="4" name="">
             <a:extLst xmlns:a="http://schemas.openxmlformats.org/drawingml/2006/main">
               <a:ext uri="{FF2B5EF4-FFF2-40B4-BE49-F238E27FC236}">
-                <a16:creationId xmlns:a16="http://schemas.microsoft.com/office/drawing/2014/main" id="{927108F4-C73D-4DFF-951D-7EDDBD953B7F}"/>
+                <a16:creationId xmlns:a16="http://schemas.microsoft.com/office/drawing/2014/main" id="{7A20F4CB-A235-42D1-8BE2-1E5E65EC7636}"/>
               </a:ext>
             </a:extLst>
           </p:cNvPr>
@@ -3795,7 +3795,7 @@
           <p:cNvPr id="5" name="">
             <a:extLst xmlns:a="http://schemas.openxmlformats.org/drawingml/2006/main">
               <a:ext uri="{FF2B5EF4-FFF2-40B4-BE49-F238E27FC236}">
-                <a16:creationId xmlns:a16="http://schemas.microsoft.com/office/drawing/2014/main" id="{0ABFE429-AEB4-497E-B6D3-85DEEADA2125}"/>
+                <a16:creationId xmlns:a16="http://schemas.microsoft.com/office/drawing/2014/main" id="{A023292E-DBBD-446B-9D25-AC978F407DE0}"/>
               </a:ext>
             </a:extLst>
           </p:cNvPr>
@@ -3861,7 +3861,7 @@
           <p:cNvPr id="6" name="">
             <a:extLst xmlns:a="http://schemas.openxmlformats.org/drawingml/2006/main">
               <a:ext uri="{FF2B5EF4-FFF2-40B4-BE49-F238E27FC236}">
-                <a16:creationId xmlns:a16="http://schemas.microsoft.com/office/drawing/2014/main" id="{784A86DE-CE83-4A0C-B881-7B017E7DE1B0}"/>
+                <a16:creationId xmlns:a16="http://schemas.microsoft.com/office/drawing/2014/main" id="{B89CACF5-3A81-427A-B78D-8A72A104D24F}"/>
               </a:ext>
             </a:extLst>
           </p:cNvPr>
@@ -3925,7 +3925,7 @@
     </p:spTree>
     <p:extLst>
       <p:ext uri="{BB962C8B-B14F-4D97-AF65-F5344CB8AC3E}">
-        <p14:creationId xmlns:p14="http://schemas.microsoft.com/office/powerpoint/2010/main" val="20062655"/>
+        <p14:creationId xmlns:p14="http://schemas.microsoft.com/office/powerpoint/2010/main" val="743287615"/>
       </p:ext>
     </p:extLst>
   </p:cSld>
@@ -3956,7 +3956,7 @@
           <p:cNvPr id="7" name="">
             <a:extLst xmlns:a="http://schemas.openxmlformats.org/drawingml/2006/main">
               <a:ext uri="{FF2B5EF4-FFF2-40B4-BE49-F238E27FC236}">
-                <a16:creationId xmlns:a16="http://schemas.microsoft.com/office/drawing/2014/main" id="{7FB20BF6-7500-48A7-8B87-227F6B835A44}"/>
+                <a16:creationId xmlns:a16="http://schemas.microsoft.com/office/drawing/2014/main" id="{22F9DA50-08D6-4480-9A37-CBF2707F301B}"/>
               </a:ext>
             </a:extLst>
           </p:cNvPr>
@@ -4022,7 +4022,7 @@
           <p:cNvPr id="2" name="">
             <a:extLst xmlns:a="http://schemas.openxmlformats.org/drawingml/2006/main">
               <a:ext uri="{FF2B5EF4-FFF2-40B4-BE49-F238E27FC236}">
-                <a16:creationId xmlns:a16="http://schemas.microsoft.com/office/drawing/2014/main" id="{DE8A2531-7A64-4A13-840C-CC8001D69956}"/>
+                <a16:creationId xmlns:a16="http://schemas.microsoft.com/office/drawing/2014/main" id="{C2B8C45D-AEC0-464C-9457-3C19A7EB579D}"/>
               </a:ext>
             </a:extLst>
           </p:cNvPr>
@@ -4088,7 +4088,7 @@
           <p:cNvPr id="3" name="">
             <a:extLst xmlns:a="http://schemas.openxmlformats.org/drawingml/2006/main">
               <a:ext uri="{FF2B5EF4-FFF2-40B4-BE49-F238E27FC236}">
-                <a16:creationId xmlns:a16="http://schemas.microsoft.com/office/drawing/2014/main" id="{E9F611BE-146E-406B-B097-FA03969547A8}"/>
+                <a16:creationId xmlns:a16="http://schemas.microsoft.com/office/drawing/2014/main" id="{28BDC876-B7F6-4F16-BAA2-6203D007C2E3}"/>
               </a:ext>
             </a:extLst>
           </p:cNvPr>
@@ -4154,7 +4154,7 @@
           <p:cNvPr id="4" name="">
             <a:extLst xmlns:a="http://schemas.openxmlformats.org/drawingml/2006/main">
               <a:ext uri="{FF2B5EF4-FFF2-40B4-BE49-F238E27FC236}">
-                <a16:creationId xmlns:a16="http://schemas.microsoft.com/office/drawing/2014/main" id="{5F01F553-D8F8-431A-8BEB-6C612850F8A1}"/>
+                <a16:creationId xmlns:a16="http://schemas.microsoft.com/office/drawing/2014/main" id="{ED0F0852-2BC6-49A2-82DA-75075B10F04A}"/>
               </a:ext>
             </a:extLst>
           </p:cNvPr>
@@ -4220,7 +4220,7 @@
           <p:cNvPr id="5" name="">
             <a:extLst xmlns:a="http://schemas.openxmlformats.org/drawingml/2006/main">
               <a:ext uri="{FF2B5EF4-FFF2-40B4-BE49-F238E27FC236}">
-                <a16:creationId xmlns:a16="http://schemas.microsoft.com/office/drawing/2014/main" id="{EA2C2585-3E89-4740-9DC9-A3D83F947AAA}"/>
+                <a16:creationId xmlns:a16="http://schemas.microsoft.com/office/drawing/2014/main" id="{CAFF54F2-4661-449F-B58F-830C341B418E}"/>
               </a:ext>
             </a:extLst>
           </p:cNvPr>
@@ -4286,7 +4286,7 @@
           <p:cNvPr id="6" name="">
             <a:extLst xmlns:a="http://schemas.openxmlformats.org/drawingml/2006/main">
               <a:ext uri="{FF2B5EF4-FFF2-40B4-BE49-F238E27FC236}">
-                <a16:creationId xmlns:a16="http://schemas.microsoft.com/office/drawing/2014/main" id="{E6985B84-FB88-4FD5-AA12-7E946014E89A}"/>
+                <a16:creationId xmlns:a16="http://schemas.microsoft.com/office/drawing/2014/main" id="{799D5EA4-1FB5-43B7-ADE3-EF6C8BA1F365}"/>
               </a:ext>
             </a:extLst>
           </p:cNvPr>
@@ -4350,7 +4350,7 @@
     </p:spTree>
     <p:extLst>
       <p:ext uri="{BB962C8B-B14F-4D97-AF65-F5344CB8AC3E}">
-        <p14:creationId xmlns:p14="http://schemas.microsoft.com/office/powerpoint/2010/main" val="1317068462"/>
+        <p14:creationId xmlns:p14="http://schemas.microsoft.com/office/powerpoint/2010/main" val="489206150"/>
       </p:ext>
     </p:extLst>
   </p:cSld>
@@ -4381,7 +4381,7 @@
           <p:cNvPr id="7" name="">
             <a:extLst xmlns:a="http://schemas.openxmlformats.org/drawingml/2006/main">
               <a:ext uri="{FF2B5EF4-FFF2-40B4-BE49-F238E27FC236}">
-                <a16:creationId xmlns:a16="http://schemas.microsoft.com/office/drawing/2014/main" id="{3D69DEE9-5397-4E85-85D5-1B1814B20F9D}"/>
+                <a16:creationId xmlns:a16="http://schemas.microsoft.com/office/drawing/2014/main" id="{BD0E1EE6-DF2F-4632-8B50-42E85AD79F09}"/>
               </a:ext>
             </a:extLst>
           </p:cNvPr>
@@ -4447,7 +4447,7 @@
           <p:cNvPr id="2" name="">
             <a:extLst xmlns:a="http://schemas.openxmlformats.org/drawingml/2006/main">
               <a:ext uri="{FF2B5EF4-FFF2-40B4-BE49-F238E27FC236}">
-                <a16:creationId xmlns:a16="http://schemas.microsoft.com/office/drawing/2014/main" id="{138D7990-5E49-4BCD-ADE1-0DBE91C77FD2}"/>
+                <a16:creationId xmlns:a16="http://schemas.microsoft.com/office/drawing/2014/main" id="{CFFFF205-8E5F-4D4E-B1EA-6DE0658C1DD6}"/>
               </a:ext>
             </a:extLst>
           </p:cNvPr>
@@ -4513,7 +4513,7 @@
           <p:cNvPr id="3" name="">
             <a:extLst xmlns:a="http://schemas.openxmlformats.org/drawingml/2006/main">
               <a:ext uri="{FF2B5EF4-FFF2-40B4-BE49-F238E27FC236}">
-                <a16:creationId xmlns:a16="http://schemas.microsoft.com/office/drawing/2014/main" id="{A048BF78-B9C4-420F-B512-2FCED688BDA4}"/>
+                <a16:creationId xmlns:a16="http://schemas.microsoft.com/office/drawing/2014/main" id="{54EBC113-F56F-42F8-A5F2-323EDAF83579}"/>
               </a:ext>
             </a:extLst>
           </p:cNvPr>
@@ -4579,7 +4579,7 @@
           <p:cNvPr id="4" name="">
             <a:extLst xmlns:a="http://schemas.openxmlformats.org/drawingml/2006/main">
               <a:ext uri="{FF2B5EF4-FFF2-40B4-BE49-F238E27FC236}">
-                <a16:creationId xmlns:a16="http://schemas.microsoft.com/office/drawing/2014/main" id="{07CA7B20-8333-4101-BA84-0A0D391E5546}"/>
+                <a16:creationId xmlns:a16="http://schemas.microsoft.com/office/drawing/2014/main" id="{225C0566-EE8A-492B-AE9D-72249E974CA7}"/>
               </a:ext>
             </a:extLst>
           </p:cNvPr>
@@ -4645,7 +4645,7 @@
           <p:cNvPr id="5" name="">
             <a:extLst xmlns:a="http://schemas.openxmlformats.org/drawingml/2006/main">
               <a:ext uri="{FF2B5EF4-FFF2-40B4-BE49-F238E27FC236}">
-                <a16:creationId xmlns:a16="http://schemas.microsoft.com/office/drawing/2014/main" id="{17A5BE60-5199-45B4-AD16-4A45B495C302}"/>
+                <a16:creationId xmlns:a16="http://schemas.microsoft.com/office/drawing/2014/main" id="{26EC888B-4600-4B66-93E4-26CD0D84D916}"/>
               </a:ext>
             </a:extLst>
           </p:cNvPr>
@@ -4711,7 +4711,7 @@
           <p:cNvPr id="6" name="">
             <a:extLst xmlns:a="http://schemas.openxmlformats.org/drawingml/2006/main">
               <a:ext uri="{FF2B5EF4-FFF2-40B4-BE49-F238E27FC236}">
-                <a16:creationId xmlns:a16="http://schemas.microsoft.com/office/drawing/2014/main" id="{E3D78DC2-097E-460B-8A1C-E68E13D25A2D}"/>
+                <a16:creationId xmlns:a16="http://schemas.microsoft.com/office/drawing/2014/main" id="{C21C0D5F-31CB-470C-96E6-EB69A47ABC99}"/>
               </a:ext>
             </a:extLst>
           </p:cNvPr>
@@ -4775,7 +4775,7 @@
     </p:spTree>
     <p:extLst>
       <p:ext uri="{BB962C8B-B14F-4D97-AF65-F5344CB8AC3E}">
-        <p14:creationId xmlns:p14="http://schemas.microsoft.com/office/powerpoint/2010/main" val="77588118"/>
+        <p14:creationId xmlns:p14="http://schemas.microsoft.com/office/powerpoint/2010/main" val="1439372232"/>
       </p:ext>
     </p:extLst>
   </p:cSld>
@@ -4806,7 +4806,7 @@
           <p:cNvPr id="8" name="">
             <a:extLst xmlns:a="http://schemas.openxmlformats.org/drawingml/2006/main">
               <a:ext uri="{FF2B5EF4-FFF2-40B4-BE49-F238E27FC236}">
-                <a16:creationId xmlns:a16="http://schemas.microsoft.com/office/drawing/2014/main" id="{8BAFEF6B-E4A9-4393-9A04-24E239F0C901}"/>
+                <a16:creationId xmlns:a16="http://schemas.microsoft.com/office/drawing/2014/main" id="{835159E6-2A09-4750-BB18-59A764C89BC3}"/>
               </a:ext>
             </a:extLst>
           </p:cNvPr>
@@ -4872,7 +4872,7 @@
           <p:cNvPr id="2" name="">
             <a:extLst xmlns:a="http://schemas.openxmlformats.org/drawingml/2006/main">
               <a:ext uri="{FF2B5EF4-FFF2-40B4-BE49-F238E27FC236}">
-                <a16:creationId xmlns:a16="http://schemas.microsoft.com/office/drawing/2014/main" id="{D88D09B6-2958-465E-B50E-13DDDAEA80A7}"/>
+                <a16:creationId xmlns:a16="http://schemas.microsoft.com/office/drawing/2014/main" id="{96434467-819F-4450-94DE-63EDA92A6BC0}"/>
               </a:ext>
             </a:extLst>
           </p:cNvPr>
@@ -4938,7 +4938,7 @@
           <p:cNvPr id="3" name="">
             <a:extLst xmlns:a="http://schemas.openxmlformats.org/drawingml/2006/main">
               <a:ext uri="{FF2B5EF4-FFF2-40B4-BE49-F238E27FC236}">
-                <a16:creationId xmlns:a16="http://schemas.microsoft.com/office/drawing/2014/main" id="{AA8C5A48-302F-40D3-9F24-74F59DB17E47}"/>
+                <a16:creationId xmlns:a16="http://schemas.microsoft.com/office/drawing/2014/main" id="{117B7C70-DC38-4656-8240-7002628E0EFD}"/>
               </a:ext>
             </a:extLst>
           </p:cNvPr>
@@ -5004,7 +5004,7 @@
           <p:cNvPr id="4" name="">
             <a:extLst xmlns:a="http://schemas.openxmlformats.org/drawingml/2006/main">
               <a:ext uri="{FF2B5EF4-FFF2-40B4-BE49-F238E27FC236}">
-                <a16:creationId xmlns:a16="http://schemas.microsoft.com/office/drawing/2014/main" id="{BA37F518-ED65-40BA-83A6-C0F6B7107712}"/>
+                <a16:creationId xmlns:a16="http://schemas.microsoft.com/office/drawing/2014/main" id="{0DCA84CB-7077-4409-9642-632F7B070249}"/>
               </a:ext>
             </a:extLst>
           </p:cNvPr>
@@ -5014,13 +5014,13 @@
           <p:nvPr/>
         </p:nvPicPr>
         <p:blipFill>
-          <a:blip xmlns:r="http://schemas.openxmlformats.org/officeDocument/2006/relationships" xmlns:a="http://schemas.openxmlformats.org/drawingml/2006/main" r:embed="R5c77726bb59d4ba6"/>
+          <a:blip xmlns:r="http://schemas.openxmlformats.org/officeDocument/2006/relationships" xmlns:a="http://schemas.openxmlformats.org/drawingml/2006/main" r:embed="R76eabb269c814aef"/>
           <a:stretch xmlns:a="http://schemas.openxmlformats.org/drawingml/2006/main"/>
         </p:blipFill>
         <p:spPr>
           <a:xfrm xmlns:a="http://schemas.openxmlformats.org/drawingml/2006/main">
-            <a:off x="609600" y="2049812"/>
-            <a:ext cx="5257800" cy="3015551"/>
+            <a:off x="609600" y="2078831"/>
+            <a:ext cx="5257800" cy="2957513"/>
           </a:xfrm>
           <a:prstGeom xmlns:a="http://schemas.openxmlformats.org/drawingml/2006/main" prst="rect">
             <a:avLst/>
@@ -5032,7 +5032,7 @@
           <p:cNvPr id="5" name="">
             <a:extLst xmlns:a="http://schemas.openxmlformats.org/drawingml/2006/main">
               <a:ext uri="{FF2B5EF4-FFF2-40B4-BE49-F238E27FC236}">
-                <a16:creationId xmlns:a16="http://schemas.microsoft.com/office/drawing/2014/main" id="{1F63FDFD-DCE2-4041-9E10-9486765647B0}"/>
+                <a16:creationId xmlns:a16="http://schemas.microsoft.com/office/drawing/2014/main" id="{7F7B6D1C-2447-4D67-8C63-E5B5228AEE8D}"/>
               </a:ext>
             </a:extLst>
           </p:cNvPr>
@@ -5042,13 +5042,13 @@
           <p:nvPr/>
         </p:nvPicPr>
         <p:blipFill>
-          <a:blip xmlns:r="http://schemas.openxmlformats.org/officeDocument/2006/relationships" xmlns:a="http://schemas.openxmlformats.org/drawingml/2006/main" r:embed="Ra78a1d06a3244b38"/>
+          <a:blip xmlns:r="http://schemas.openxmlformats.org/officeDocument/2006/relationships" xmlns:a="http://schemas.openxmlformats.org/drawingml/2006/main" r:embed="R656bf163023949b2"/>
           <a:stretch xmlns:a="http://schemas.openxmlformats.org/drawingml/2006/main"/>
         </p:blipFill>
         <p:spPr>
           <a:xfrm xmlns:a="http://schemas.openxmlformats.org/drawingml/2006/main">
-            <a:off x="6324600" y="2049812"/>
-            <a:ext cx="5257800" cy="3015551"/>
+            <a:off x="6324600" y="2078831"/>
+            <a:ext cx="5257800" cy="2957513"/>
           </a:xfrm>
           <a:prstGeom xmlns:a="http://schemas.openxmlformats.org/drawingml/2006/main" prst="rect">
             <a:avLst/>
@@ -5060,7 +5060,7 @@
           <p:cNvPr id="6" name="">
             <a:extLst xmlns:a="http://schemas.openxmlformats.org/drawingml/2006/main">
               <a:ext uri="{FF2B5EF4-FFF2-40B4-BE49-F238E27FC236}">
-                <a16:creationId xmlns:a16="http://schemas.microsoft.com/office/drawing/2014/main" id="{0B2199BB-7A37-4908-A403-10DD9CD00ED5}"/>
+                <a16:creationId xmlns:a16="http://schemas.microsoft.com/office/drawing/2014/main" id="{34FF1E04-3B0B-4743-9928-3773A1552F0A}"/>
               </a:ext>
             </a:extLst>
           </p:cNvPr>
@@ -5116,7 +5116,7 @@
                 <a:ea typeface="Tahoma"/>
                 <a:cs typeface="Tahoma"/>
               </a:rPr>
-              <a:t>รอบ 1 = COMPLETED</a:t>
+              <a:t>รอบ 5 = เสร็จสิ้น</a:t>
             </a:r>
           </a:p>
         </p:txBody>
@@ -5126,7 +5126,7 @@
           <p:cNvPr id="7" name="">
             <a:extLst xmlns:a="http://schemas.openxmlformats.org/drawingml/2006/main">
               <a:ext uri="{FF2B5EF4-FFF2-40B4-BE49-F238E27FC236}">
-                <a16:creationId xmlns:a16="http://schemas.microsoft.com/office/drawing/2014/main" id="{2265D58E-2941-46B6-9D8A-DA18056E8049}"/>
+                <a16:creationId xmlns:a16="http://schemas.microsoft.com/office/drawing/2014/main" id="{52BCFFF8-C622-44A7-B4F2-3BD3407E147F}"/>
               </a:ext>
             </a:extLst>
           </p:cNvPr>
@@ -5182,7 +5182,7 @@
                 <a:ea typeface="Tahoma"/>
                 <a:cs typeface="Tahoma"/>
               </a:rPr>
-              <a:t>เครื่อง 2 = AVAILABLE</a:t>
+              <a:t>เครื่อง 2 = ว่าง</a:t>
             </a:r>
           </a:p>
         </p:txBody>
@@ -5190,7 +5190,7 @@
     </p:spTree>
     <p:extLst>
       <p:ext uri="{BB962C8B-B14F-4D97-AF65-F5344CB8AC3E}">
-        <p14:creationId xmlns:p14="http://schemas.microsoft.com/office/powerpoint/2010/main" val="190672258"/>
+        <p14:creationId xmlns:p14="http://schemas.microsoft.com/office/powerpoint/2010/main" val="549182416"/>
       </p:ext>
     </p:extLst>
   </p:cSld>
@@ -5221,7 +5221,7 @@
           <p:cNvPr id="7" name="">
             <a:extLst xmlns:a="http://schemas.openxmlformats.org/drawingml/2006/main">
               <a:ext uri="{FF2B5EF4-FFF2-40B4-BE49-F238E27FC236}">
-                <a16:creationId xmlns:a16="http://schemas.microsoft.com/office/drawing/2014/main" id="{50FF017E-669D-4701-B12A-2648CDDE6F16}"/>
+                <a16:creationId xmlns:a16="http://schemas.microsoft.com/office/drawing/2014/main" id="{372E256A-F24A-43D4-AC48-2BE8E02AB2FA}"/>
               </a:ext>
             </a:extLst>
           </p:cNvPr>
@@ -5287,7 +5287,7 @@
           <p:cNvPr id="2" name="">
             <a:extLst xmlns:a="http://schemas.openxmlformats.org/drawingml/2006/main">
               <a:ext uri="{FF2B5EF4-FFF2-40B4-BE49-F238E27FC236}">
-                <a16:creationId xmlns:a16="http://schemas.microsoft.com/office/drawing/2014/main" id="{69311AF2-C42C-43F4-9734-30791BA7C558}"/>
+                <a16:creationId xmlns:a16="http://schemas.microsoft.com/office/drawing/2014/main" id="{2B345050-A09E-42AB-9D54-0C756E496EFF}"/>
               </a:ext>
             </a:extLst>
           </p:cNvPr>
@@ -5343,7 +5343,7 @@
                 <a:ea typeface="Tahoma"/>
                 <a:cs typeface="Tahoma"/>
               </a:rPr>
-              <a:t>Maven ล่าสุด: 369 รายการ ผ่าน 333 ข้าม PostgreSQL 36</a:t>
+              <a:t>Maven ล่าสุด: 376 รายการ ผ่าน 340 ข้าม PostgreSQL 36</a:t>
             </a:r>
           </a:p>
         </p:txBody>
@@ -5353,7 +5353,7 @@
           <p:cNvPr id="3" name="">
             <a:extLst xmlns:a="http://schemas.openxmlformats.org/drawingml/2006/main">
               <a:ext uri="{FF2B5EF4-FFF2-40B4-BE49-F238E27FC236}">
-                <a16:creationId xmlns:a16="http://schemas.microsoft.com/office/drawing/2014/main" id="{DBAA7577-5B2C-4D5E-A2F4-B61E8E39400B}"/>
+                <a16:creationId xmlns:a16="http://schemas.microsoft.com/office/drawing/2014/main" id="{64355649-5A7D-435B-BFB8-4C322E840117}"/>
               </a:ext>
             </a:extLst>
           </p:cNvPr>
@@ -5419,7 +5419,7 @@
           <p:cNvPr id="4" name="">
             <a:extLst xmlns:a="http://schemas.openxmlformats.org/drawingml/2006/main">
               <a:ext uri="{FF2B5EF4-FFF2-40B4-BE49-F238E27FC236}">
-                <a16:creationId xmlns:a16="http://schemas.microsoft.com/office/drawing/2014/main" id="{378A759A-3320-4E0F-A7EE-0B7187DFF486}"/>
+                <a16:creationId xmlns:a16="http://schemas.microsoft.com/office/drawing/2014/main" id="{AA9EF906-DA59-4D61-A2AE-88AE503C756F}"/>
               </a:ext>
             </a:extLst>
           </p:cNvPr>
@@ -5485,7 +5485,7 @@
           <p:cNvPr id="5" name="">
             <a:extLst xmlns:a="http://schemas.openxmlformats.org/drawingml/2006/main">
               <a:ext uri="{FF2B5EF4-FFF2-40B4-BE49-F238E27FC236}">
-                <a16:creationId xmlns:a16="http://schemas.microsoft.com/office/drawing/2014/main" id="{5410C286-1EB0-4101-BF04-2C8C61CFACF7}"/>
+                <a16:creationId xmlns:a16="http://schemas.microsoft.com/office/drawing/2014/main" id="{DDCA03F3-EF1D-400D-994C-00B221C3D833}"/>
               </a:ext>
             </a:extLst>
           </p:cNvPr>
@@ -5551,7 +5551,7 @@
           <p:cNvPr id="6" name="">
             <a:extLst xmlns:a="http://schemas.openxmlformats.org/drawingml/2006/main">
               <a:ext uri="{FF2B5EF4-FFF2-40B4-BE49-F238E27FC236}">
-                <a16:creationId xmlns:a16="http://schemas.microsoft.com/office/drawing/2014/main" id="{FB67F66E-E973-4E6B-94B7-517CC16A4E59}"/>
+                <a16:creationId xmlns:a16="http://schemas.microsoft.com/office/drawing/2014/main" id="{097E6898-41FD-422C-A3C3-0563B68AB0E1}"/>
               </a:ext>
             </a:extLst>
           </p:cNvPr>
@@ -5615,7 +5615,7 @@
     </p:spTree>
     <p:extLst>
       <p:ext uri="{BB962C8B-B14F-4D97-AF65-F5344CB8AC3E}">
-        <p14:creationId xmlns:p14="http://schemas.microsoft.com/office/powerpoint/2010/main" val="957780589"/>
+        <p14:creationId xmlns:p14="http://schemas.microsoft.com/office/powerpoint/2010/main" val="887500674"/>
       </p:ext>
     </p:extLst>
   </p:cSld>

</xml_diff>